<commit_message>
Fix BT wrong execution index
</commit_message>
<xml_diff>
--- a/GPP_ZombieAI_MouchriqueThymme_2DAE19.pptx
+++ b/GPP_ZombieAI_MouchriqueThymme_2DAE19.pptx
@@ -11,7 +11,6 @@
     <p:sldId id="258" r:id="rId8"/>
     <p:sldId id="259" r:id="rId9"/>
     <p:sldId id="262" r:id="rId10"/>
-    <p:sldId id="261" r:id="rId11"/>
   </p:sldIdLst>
   <p:sldSz cx="12192000" cy="6858000"/>
   <p:notesSz cx="6858000" cy="9144000"/>
@@ -405,7 +404,7 @@
           <a:p>
             <a:fld id="{82085877-2B37-48E7-8B6D-4D4ED486130A}" type="datetimeFigureOut">
               <a:rPr lang="en-BE" smtClean="0"/>
-              <a:t>11/28/2023</a:t>
+              <a:t>06/04/2026</a:t>
             </a:fld>
             <a:endParaRPr lang="en-BE"/>
           </a:p>
@@ -459,7 +458,7 @@
           <a:p>
             <a:fld id="{F15161DE-E191-4798-91BE-355EA90292A5}" type="slidenum">
               <a:rPr lang="en-BE" smtClean="0"/>
-              <a:t>‹#›</a:t>
+              <a:t>‹nr.›</a:t>
             </a:fld>
             <a:endParaRPr lang="en-BE"/>
           </a:p>
@@ -605,7 +604,7 @@
           <a:p>
             <a:fld id="{82085877-2B37-48E7-8B6D-4D4ED486130A}" type="datetimeFigureOut">
               <a:rPr lang="en-BE" smtClean="0"/>
-              <a:t>11/28/2023</a:t>
+              <a:t>06/04/2026</a:t>
             </a:fld>
             <a:endParaRPr lang="en-BE"/>
           </a:p>
@@ -659,7 +658,7 @@
           <a:p>
             <a:fld id="{F15161DE-E191-4798-91BE-355EA90292A5}" type="slidenum">
               <a:rPr lang="en-BE" smtClean="0"/>
-              <a:t>‹#›</a:t>
+              <a:t>‹nr.›</a:t>
             </a:fld>
             <a:endParaRPr lang="en-BE"/>
           </a:p>
@@ -815,7 +814,7 @@
           <a:p>
             <a:fld id="{82085877-2B37-48E7-8B6D-4D4ED486130A}" type="datetimeFigureOut">
               <a:rPr lang="en-BE" smtClean="0"/>
-              <a:t>11/28/2023</a:t>
+              <a:t>06/04/2026</a:t>
             </a:fld>
             <a:endParaRPr lang="en-BE"/>
           </a:p>
@@ -869,7 +868,7 @@
           <a:p>
             <a:fld id="{F15161DE-E191-4798-91BE-355EA90292A5}" type="slidenum">
               <a:rPr lang="en-BE" smtClean="0"/>
-              <a:t>‹#›</a:t>
+              <a:t>‹nr.›</a:t>
             </a:fld>
             <a:endParaRPr lang="en-BE"/>
           </a:p>
@@ -1015,7 +1014,7 @@
           <a:p>
             <a:fld id="{82085877-2B37-48E7-8B6D-4D4ED486130A}" type="datetimeFigureOut">
               <a:rPr lang="en-BE" smtClean="0"/>
-              <a:t>11/28/2023</a:t>
+              <a:t>06/04/2026</a:t>
             </a:fld>
             <a:endParaRPr lang="en-BE"/>
           </a:p>
@@ -1069,7 +1068,7 @@
           <a:p>
             <a:fld id="{F15161DE-E191-4798-91BE-355EA90292A5}" type="slidenum">
               <a:rPr lang="en-BE" smtClean="0"/>
-              <a:t>‹#›</a:t>
+              <a:t>‹nr.›</a:t>
             </a:fld>
             <a:endParaRPr lang="en-BE"/>
           </a:p>
@@ -1291,7 +1290,7 @@
           <a:p>
             <a:fld id="{82085877-2B37-48E7-8B6D-4D4ED486130A}" type="datetimeFigureOut">
               <a:rPr lang="en-BE" smtClean="0"/>
-              <a:t>11/28/2023</a:t>
+              <a:t>06/04/2026</a:t>
             </a:fld>
             <a:endParaRPr lang="en-BE"/>
           </a:p>
@@ -1345,7 +1344,7 @@
           <a:p>
             <a:fld id="{F15161DE-E191-4798-91BE-355EA90292A5}" type="slidenum">
               <a:rPr lang="en-BE" smtClean="0"/>
-              <a:t>‹#›</a:t>
+              <a:t>‹nr.›</a:t>
             </a:fld>
             <a:endParaRPr lang="en-BE"/>
           </a:p>
@@ -1559,7 +1558,7 @@
           <a:p>
             <a:fld id="{82085877-2B37-48E7-8B6D-4D4ED486130A}" type="datetimeFigureOut">
               <a:rPr lang="en-BE" smtClean="0"/>
-              <a:t>11/28/2023</a:t>
+              <a:t>06/04/2026</a:t>
             </a:fld>
             <a:endParaRPr lang="en-BE"/>
           </a:p>
@@ -1613,7 +1612,7 @@
           <a:p>
             <a:fld id="{F15161DE-E191-4798-91BE-355EA90292A5}" type="slidenum">
               <a:rPr lang="en-BE" smtClean="0"/>
-              <a:t>‹#›</a:t>
+              <a:t>‹nr.›</a:t>
             </a:fld>
             <a:endParaRPr lang="en-BE"/>
           </a:p>
@@ -1974,7 +1973,7 @@
           <a:p>
             <a:fld id="{82085877-2B37-48E7-8B6D-4D4ED486130A}" type="datetimeFigureOut">
               <a:rPr lang="en-BE" smtClean="0"/>
-              <a:t>11/28/2023</a:t>
+              <a:t>06/04/2026</a:t>
             </a:fld>
             <a:endParaRPr lang="en-BE"/>
           </a:p>
@@ -2028,7 +2027,7 @@
           <a:p>
             <a:fld id="{F15161DE-E191-4798-91BE-355EA90292A5}" type="slidenum">
               <a:rPr lang="en-BE" smtClean="0"/>
-              <a:t>‹#›</a:t>
+              <a:t>‹nr.›</a:t>
             </a:fld>
             <a:endParaRPr lang="en-BE"/>
           </a:p>
@@ -2116,7 +2115,7 @@
           <a:p>
             <a:fld id="{82085877-2B37-48E7-8B6D-4D4ED486130A}" type="datetimeFigureOut">
               <a:rPr lang="en-BE" smtClean="0"/>
-              <a:t>11/28/2023</a:t>
+              <a:t>06/04/2026</a:t>
             </a:fld>
             <a:endParaRPr lang="en-BE"/>
           </a:p>
@@ -2170,7 +2169,7 @@
           <a:p>
             <a:fld id="{F15161DE-E191-4798-91BE-355EA90292A5}" type="slidenum">
               <a:rPr lang="en-BE" smtClean="0"/>
-              <a:t>‹#›</a:t>
+              <a:t>‹nr.›</a:t>
             </a:fld>
             <a:endParaRPr lang="en-BE"/>
           </a:p>
@@ -2229,7 +2228,7 @@
           <a:p>
             <a:fld id="{82085877-2B37-48E7-8B6D-4D4ED486130A}" type="datetimeFigureOut">
               <a:rPr lang="en-BE" smtClean="0"/>
-              <a:t>11/28/2023</a:t>
+              <a:t>06/04/2026</a:t>
             </a:fld>
             <a:endParaRPr lang="en-BE"/>
           </a:p>
@@ -2283,7 +2282,7 @@
           <a:p>
             <a:fld id="{F15161DE-E191-4798-91BE-355EA90292A5}" type="slidenum">
               <a:rPr lang="en-BE" smtClean="0"/>
-              <a:t>‹#›</a:t>
+              <a:t>‹nr.›</a:t>
             </a:fld>
             <a:endParaRPr lang="en-BE"/>
           </a:p>
@@ -2542,7 +2541,7 @@
           <a:p>
             <a:fld id="{82085877-2B37-48E7-8B6D-4D4ED486130A}" type="datetimeFigureOut">
               <a:rPr lang="en-BE" smtClean="0"/>
-              <a:t>11/28/2023</a:t>
+              <a:t>06/04/2026</a:t>
             </a:fld>
             <a:endParaRPr lang="en-BE"/>
           </a:p>
@@ -2596,7 +2595,7 @@
           <a:p>
             <a:fld id="{F15161DE-E191-4798-91BE-355EA90292A5}" type="slidenum">
               <a:rPr lang="en-BE" smtClean="0"/>
-              <a:t>‹#›</a:t>
+              <a:t>‹nr.›</a:t>
             </a:fld>
             <a:endParaRPr lang="en-BE"/>
           </a:p>
@@ -2831,7 +2830,7 @@
           <a:p>
             <a:fld id="{82085877-2B37-48E7-8B6D-4D4ED486130A}" type="datetimeFigureOut">
               <a:rPr lang="en-BE" smtClean="0"/>
-              <a:t>11/28/2023</a:t>
+              <a:t>06/04/2026</a:t>
             </a:fld>
             <a:endParaRPr lang="en-BE"/>
           </a:p>
@@ -2885,7 +2884,7 @@
           <a:p>
             <a:fld id="{F15161DE-E191-4798-91BE-355EA90292A5}" type="slidenum">
               <a:rPr lang="en-BE" smtClean="0"/>
-              <a:t>‹#›</a:t>
+              <a:t>‹nr.›</a:t>
             </a:fld>
             <a:endParaRPr lang="en-BE"/>
           </a:p>
@@ -3074,7 +3073,7 @@
           <a:p>
             <a:fld id="{82085877-2B37-48E7-8B6D-4D4ED486130A}" type="datetimeFigureOut">
               <a:rPr lang="en-BE" smtClean="0"/>
-              <a:t>11/28/2023</a:t>
+              <a:t>06/04/2026</a:t>
             </a:fld>
             <a:endParaRPr lang="en-BE"/>
           </a:p>
@@ -3164,7 +3163,7 @@
           <a:p>
             <a:fld id="{F15161DE-E191-4798-91BE-355EA90292A5}" type="slidenum">
               <a:rPr lang="en-BE" smtClean="0"/>
-              <a:t>‹#›</a:t>
+              <a:t>‹nr.›</a:t>
             </a:fld>
             <a:endParaRPr lang="en-BE"/>
           </a:p>
@@ -3541,29 +3540,7 @@
           <a:bodyPr/>
           <a:lstStyle/>
           <a:p>
-            <a:r>
-              <a:rPr lang="en-US" i="1">
-                <a:solidFill>
-                  <a:schemeClr val="bg1">
-                    <a:lumMod val="75000"/>
-                  </a:schemeClr>
-                </a:solidFill>
-              </a:rPr>
-              <a:t>Delete all comments after reading</a:t>
-            </a:r>
-          </a:p>
-          <a:p>
-            <a:r>
-              <a:rPr lang="en-US" i="1">
-                <a:solidFill>
-                  <a:schemeClr val="bg1">
-                    <a:lumMod val="75000"/>
-                  </a:schemeClr>
-                </a:solidFill>
-              </a:rPr>
-              <a:t>You are not allowed to add more slides to this presentation</a:t>
-            </a:r>
-            <a:endParaRPr lang="en-BE" i="1">
+            <a:endParaRPr lang="en-BE" i="1" dirty="0">
               <a:solidFill>
                 <a:schemeClr val="bg1">
                   <a:lumMod val="75000"/>
@@ -3625,10 +3602,10 @@
           <a:lstStyle/>
           <a:p>
             <a:r>
-              <a:rPr lang="en-US"/>
+              <a:rPr lang="en-US" dirty="0"/>
               <a:t>Decision Making</a:t>
             </a:r>
-            <a:endParaRPr lang="en-BE"/>
+            <a:endParaRPr lang="en-BE" dirty="0"/>
           </a:p>
         </p:txBody>
       </p:sp>
@@ -4127,109 +4104,6 @@
     <p:extLst>
       <p:ext uri="{BB962C8B-B14F-4D97-AF65-F5344CB8AC3E}">
         <p14:creationId xmlns:p14="http://schemas.microsoft.com/office/powerpoint/2010/main" val="1652142467"/>
-      </p:ext>
-    </p:extLst>
-  </p:cSld>
-  <p:clrMapOvr>
-    <a:masterClrMapping/>
-  </p:clrMapOvr>
-</p:sld>
-</file>
-
-<file path=ppt/slides/slide7.xml><?xml version="1.0" encoding="utf-8"?>
-<p:sld xmlns:a="http://schemas.openxmlformats.org/drawingml/2006/main" xmlns:r="http://schemas.openxmlformats.org/officeDocument/2006/relationships" xmlns:p="http://schemas.openxmlformats.org/presentationml/2006/main">
-  <p:cSld>
-    <p:spTree>
-      <p:nvGrpSpPr>
-        <p:cNvPr id="1" name=""/>
-        <p:cNvGrpSpPr/>
-        <p:nvPr/>
-      </p:nvGrpSpPr>
-      <p:grpSpPr>
-        <a:xfrm>
-          <a:off x="0" y="0"/>
-          <a:ext cx="0" cy="0"/>
-          <a:chOff x="0" y="0"/>
-          <a:chExt cx="0" cy="0"/>
-        </a:xfrm>
-      </p:grpSpPr>
-      <p:sp>
-        <p:nvSpPr>
-          <p:cNvPr id="2" name="Title 1">
-            <a:extLst>
-              <a:ext uri="{FF2B5EF4-FFF2-40B4-BE49-F238E27FC236}">
-                <a16:creationId xmlns:a16="http://schemas.microsoft.com/office/drawing/2014/main" id="{EF6BB071-C63E-40D3-93C6-9F99F27862FE}"/>
-              </a:ext>
-            </a:extLst>
-          </p:cNvPr>
-          <p:cNvSpPr>
-            <a:spLocks noGrp="1"/>
-          </p:cNvSpPr>
-          <p:nvPr>
-            <p:ph type="title"/>
-          </p:nvPr>
-        </p:nvSpPr>
-        <p:spPr/>
-        <p:txBody>
-          <a:bodyPr/>
-          <a:lstStyle/>
-          <a:p>
-            <a:r>
-              <a:rPr lang="en-US"/>
-              <a:t>High Score</a:t>
-            </a:r>
-            <a:endParaRPr lang="en-BE"/>
-          </a:p>
-        </p:txBody>
-      </p:sp>
-      <p:sp>
-        <p:nvSpPr>
-          <p:cNvPr id="3" name="Content Placeholder 2">
-            <a:extLst>
-              <a:ext uri="{FF2B5EF4-FFF2-40B4-BE49-F238E27FC236}">
-                <a16:creationId xmlns:a16="http://schemas.microsoft.com/office/drawing/2014/main" id="{64915428-ACD8-4B22-96DC-2806680ED3AB}"/>
-              </a:ext>
-            </a:extLst>
-          </p:cNvPr>
-          <p:cNvSpPr>
-            <a:spLocks noGrp="1"/>
-          </p:cNvSpPr>
-          <p:nvPr>
-            <p:ph idx="1"/>
-          </p:nvPr>
-        </p:nvSpPr>
-        <p:spPr/>
-        <p:txBody>
-          <a:bodyPr/>
-          <a:lstStyle/>
-          <a:p>
-            <a:pPr marL="0" indent="0">
-              <a:buNone/>
-            </a:pPr>
-            <a:r>
-              <a:rPr lang="en-US">
-                <a:solidFill>
-                  <a:schemeClr val="bg1">
-                    <a:lumMod val="75000"/>
-                  </a:schemeClr>
-                </a:solidFill>
-              </a:rPr>
-              <a:t>Screen shot or list of highest scores</a:t>
-            </a:r>
-            <a:endParaRPr lang="en-BE">
-              <a:solidFill>
-                <a:schemeClr val="bg1">
-                  <a:lumMod val="75000"/>
-                </a:schemeClr>
-              </a:solidFill>
-            </a:endParaRPr>
-          </a:p>
-        </p:txBody>
-      </p:sp>
-    </p:spTree>
-    <p:extLst>
-      <p:ext uri="{BB962C8B-B14F-4D97-AF65-F5344CB8AC3E}">
-        <p14:creationId xmlns:p14="http://schemas.microsoft.com/office/powerpoint/2010/main" val="3423734040"/>
       </p:ext>
     </p:extLst>
   </p:cSld>
@@ -4544,6 +4418,21 @@
 </file>
 
 <file path=customXml/item2.xml><?xml version="1.0" encoding="utf-8"?>
+<p:properties xmlns:p="http://schemas.microsoft.com/office/2006/metadata/properties" xmlns:xsi="http://www.w3.org/2001/XMLSchema-instance" xmlns:pc="http://schemas.microsoft.com/office/infopath/2007/PartnerControls">
+  <documentManagement>
+    <IconOverlay xmlns="http://schemas.microsoft.com/sharepoint/v4" xsi:nil="true"/>
+    <TaxCatchAll xmlns="128482ec-0431-40d5-ab26-89ea2a4f3ccd" xsi:nil="true"/>
+    <m99485b88215436a82099f8287cba0b0 xmlns="128482ec-0431-40d5-ab26-89ea2a4f3ccd">
+      <Terms xmlns="http://schemas.microsoft.com/office/infopath/2007/PartnerControls"/>
+    </m99485b88215436a82099f8287cba0b0>
+    <lcf76f155ced4ddcb4097134ff3c332f xmlns="60eb0cf4-ae2a-4762-800a-cb593b869ecb">
+      <Terms xmlns="http://schemas.microsoft.com/office/infopath/2007/PartnerControls"/>
+    </lcf76f155ced4ddcb4097134ff3c332f>
+  </documentManagement>
+</p:properties>
+</file>
+
+<file path=customXml/item3.xml><?xml version="1.0" encoding="utf-8"?>
 <ct:contentTypeSchema xmlns:ct="http://schemas.microsoft.com/office/2006/metadata/contentType" xmlns:ma="http://schemas.microsoft.com/office/2006/metadata/properties/metaAttributes" ct:_="" ma:_="" ma:contentTypeName="Document" ma:contentTypeID="0x010100723942CCEB3A674D8F1F6472CCEFB38E" ma:contentTypeVersion="11" ma:contentTypeDescription="Create a new document." ma:contentTypeScope="" ma:versionID="e4de40d148e029d40e3aaddc8bf68a5e">
   <xsd:schema xmlns:xsd="http://www.w3.org/2001/XMLSchema" xmlns:xs="http://www.w3.org/2001/XMLSchema" xmlns:p="http://schemas.microsoft.com/office/2006/metadata/properties" xmlns:ns2="128482ec-0431-40d5-ab26-89ea2a4f3ccd" xmlns:ns3="60eb0cf4-ae2a-4762-800a-cb593b869ecb" xmlns:ns4="http://schemas.microsoft.com/sharepoint/v4" xmlns:ns5="a2e691a9-fcfc-4d85-a390-1894fe98bd9e" targetNamespace="http://schemas.microsoft.com/office/2006/metadata/properties" ma:root="true" ma:fieldsID="fce8e8bd091658f3fe51b22d57dec109" ns2:_="" ns3:_="" ns4:_="" ns5:_="">
     <xsd:import namespace="128482ec-0431-40d5-ab26-89ea2a4f3ccd"/>
@@ -4816,21 +4705,6 @@
 </ct:contentTypeSchema>
 </file>
 
-<file path=customXml/item3.xml><?xml version="1.0" encoding="utf-8"?>
-<p:properties xmlns:p="http://schemas.microsoft.com/office/2006/metadata/properties" xmlns:xsi="http://www.w3.org/2001/XMLSchema-instance" xmlns:pc="http://schemas.microsoft.com/office/infopath/2007/PartnerControls">
-  <documentManagement>
-    <IconOverlay xmlns="http://schemas.microsoft.com/sharepoint/v4" xsi:nil="true"/>
-    <TaxCatchAll xmlns="128482ec-0431-40d5-ab26-89ea2a4f3ccd" xsi:nil="true"/>
-    <m99485b88215436a82099f8287cba0b0 xmlns="128482ec-0431-40d5-ab26-89ea2a4f3ccd">
-      <Terms xmlns="http://schemas.microsoft.com/office/infopath/2007/PartnerControls"/>
-    </m99485b88215436a82099f8287cba0b0>
-    <lcf76f155ced4ddcb4097134ff3c332f xmlns="60eb0cf4-ae2a-4762-800a-cb593b869ecb">
-      <Terms xmlns="http://schemas.microsoft.com/office/infopath/2007/PartnerControls"/>
-    </lcf76f155ced4ddcb4097134ff3c332f>
-  </documentManagement>
-</p:properties>
-</file>
-
 <file path=customXml/itemProps1.xml><?xml version="1.0" encoding="utf-8"?>
 <ds:datastoreItem xmlns:ds="http://schemas.openxmlformats.org/officeDocument/2006/customXml" ds:itemID="{AF8EC6D1-CB19-4400-AD0A-0C75CD884AEA}">
   <ds:schemaRefs>
@@ -4840,6 +4714,18 @@
 </file>
 
 <file path=customXml/itemProps2.xml><?xml version="1.0" encoding="utf-8"?>
+<ds:datastoreItem xmlns:ds="http://schemas.openxmlformats.org/officeDocument/2006/customXml" ds:itemID="{B743389A-7EE0-4951-8919-E91DD69E3687}">
+  <ds:schemaRefs>
+    <ds:schemaRef ds:uri="128482ec-0431-40d5-ab26-89ea2a4f3ccd"/>
+    <ds:schemaRef ds:uri="http://schemas.microsoft.com/office/2006/metadata/properties"/>
+    <ds:schemaRef ds:uri="http://schemas.microsoft.com/office/infopath/2007/PartnerControls"/>
+    <ds:schemaRef ds:uri="http://schemas.microsoft.com/sharepoint/v4"/>
+    <ds:schemaRef ds:uri="60eb0cf4-ae2a-4762-800a-cb593b869ecb"/>
+  </ds:schemaRefs>
+</ds:datastoreItem>
+</file>
+
+<file path=customXml/itemProps3.xml><?xml version="1.0" encoding="utf-8"?>
 <ds:datastoreItem xmlns:ds="http://schemas.openxmlformats.org/officeDocument/2006/customXml" ds:itemID="{D7B8C5DE-3345-4025-A942-C5AA68E55545}">
   <ds:schemaRefs>
     <ds:schemaRef ds:uri="http://schemas.microsoft.com/office/2006/metadata/contentType"/>
@@ -4858,16 +4744,4 @@
     <ds:schemaRef ds:uri="http://schemas.microsoft.com/internal/obd"/>
   </ds:schemaRefs>
 </ds:datastoreItem>
-</file>
-
-<file path=customXml/itemProps3.xml><?xml version="1.0" encoding="utf-8"?>
-<ds:datastoreItem xmlns:ds="http://schemas.openxmlformats.org/officeDocument/2006/customXml" ds:itemID="{B743389A-7EE0-4951-8919-E91DD69E3687}">
-  <ds:schemaRefs>
-    <ds:schemaRef ds:uri="128482ec-0431-40d5-ab26-89ea2a4f3ccd"/>
-    <ds:schemaRef ds:uri="http://schemas.microsoft.com/office/2006/metadata/properties"/>
-    <ds:schemaRef ds:uri="http://schemas.microsoft.com/office/infopath/2007/PartnerControls"/>
-    <ds:schemaRef ds:uri="http://schemas.microsoft.com/sharepoint/v4"/>
-    <ds:schemaRef ds:uri="60eb0cf4-ae2a-4762-800a-cb593b869ecb"/>
-  </ds:schemaRefs>
-</ds:datastoreItem>
 </file>
</xml_diff>

<commit_message>
Update pptx & fix player stuck
Fix player being stuck after entering firing state but not having enough ammo to kill enemy
</commit_message>
<xml_diff>
--- a/GPP_ZombieAI_MouchriqueThymme_2DAE19.pptx
+++ b/GPP_ZombieAI_MouchriqueThymme_2DAE19.pptx
@@ -404,7 +404,7 @@
           <a:p>
             <a:fld id="{82085877-2B37-48E7-8B6D-4D4ED486130A}" type="datetimeFigureOut">
               <a:rPr lang="en-BE" smtClean="0"/>
-              <a:t>06/04/2026</a:t>
+              <a:t>06/05/2026</a:t>
             </a:fld>
             <a:endParaRPr lang="en-BE"/>
           </a:p>
@@ -604,7 +604,7 @@
           <a:p>
             <a:fld id="{82085877-2B37-48E7-8B6D-4D4ED486130A}" type="datetimeFigureOut">
               <a:rPr lang="en-BE" smtClean="0"/>
-              <a:t>06/04/2026</a:t>
+              <a:t>06/05/2026</a:t>
             </a:fld>
             <a:endParaRPr lang="en-BE"/>
           </a:p>
@@ -814,7 +814,7 @@
           <a:p>
             <a:fld id="{82085877-2B37-48E7-8B6D-4D4ED486130A}" type="datetimeFigureOut">
               <a:rPr lang="en-BE" smtClean="0"/>
-              <a:t>06/04/2026</a:t>
+              <a:t>06/05/2026</a:t>
             </a:fld>
             <a:endParaRPr lang="en-BE"/>
           </a:p>
@@ -1014,7 +1014,7 @@
           <a:p>
             <a:fld id="{82085877-2B37-48E7-8B6D-4D4ED486130A}" type="datetimeFigureOut">
               <a:rPr lang="en-BE" smtClean="0"/>
-              <a:t>06/04/2026</a:t>
+              <a:t>06/05/2026</a:t>
             </a:fld>
             <a:endParaRPr lang="en-BE"/>
           </a:p>
@@ -1290,7 +1290,7 @@
           <a:p>
             <a:fld id="{82085877-2B37-48E7-8B6D-4D4ED486130A}" type="datetimeFigureOut">
               <a:rPr lang="en-BE" smtClean="0"/>
-              <a:t>06/04/2026</a:t>
+              <a:t>06/05/2026</a:t>
             </a:fld>
             <a:endParaRPr lang="en-BE"/>
           </a:p>
@@ -1558,7 +1558,7 @@
           <a:p>
             <a:fld id="{82085877-2B37-48E7-8B6D-4D4ED486130A}" type="datetimeFigureOut">
               <a:rPr lang="en-BE" smtClean="0"/>
-              <a:t>06/04/2026</a:t>
+              <a:t>06/05/2026</a:t>
             </a:fld>
             <a:endParaRPr lang="en-BE"/>
           </a:p>
@@ -1973,7 +1973,7 @@
           <a:p>
             <a:fld id="{82085877-2B37-48E7-8B6D-4D4ED486130A}" type="datetimeFigureOut">
               <a:rPr lang="en-BE" smtClean="0"/>
-              <a:t>06/04/2026</a:t>
+              <a:t>06/05/2026</a:t>
             </a:fld>
             <a:endParaRPr lang="en-BE"/>
           </a:p>
@@ -2115,7 +2115,7 @@
           <a:p>
             <a:fld id="{82085877-2B37-48E7-8B6D-4D4ED486130A}" type="datetimeFigureOut">
               <a:rPr lang="en-BE" smtClean="0"/>
-              <a:t>06/04/2026</a:t>
+              <a:t>06/05/2026</a:t>
             </a:fld>
             <a:endParaRPr lang="en-BE"/>
           </a:p>
@@ -2228,7 +2228,7 @@
           <a:p>
             <a:fld id="{82085877-2B37-48E7-8B6D-4D4ED486130A}" type="datetimeFigureOut">
               <a:rPr lang="en-BE" smtClean="0"/>
-              <a:t>06/04/2026</a:t>
+              <a:t>06/05/2026</a:t>
             </a:fld>
             <a:endParaRPr lang="en-BE"/>
           </a:p>
@@ -2541,7 +2541,7 @@
           <a:p>
             <a:fld id="{82085877-2B37-48E7-8B6D-4D4ED486130A}" type="datetimeFigureOut">
               <a:rPr lang="en-BE" smtClean="0"/>
-              <a:t>06/04/2026</a:t>
+              <a:t>06/05/2026</a:t>
             </a:fld>
             <a:endParaRPr lang="en-BE"/>
           </a:p>
@@ -2830,7 +2830,7 @@
           <a:p>
             <a:fld id="{82085877-2B37-48E7-8B6D-4D4ED486130A}" type="datetimeFigureOut">
               <a:rPr lang="en-BE" smtClean="0"/>
-              <a:t>06/04/2026</a:t>
+              <a:t>06/05/2026</a:t>
             </a:fld>
             <a:endParaRPr lang="en-BE"/>
           </a:p>
@@ -3073,7 +3073,7 @@
           <a:p>
             <a:fld id="{82085877-2B37-48E7-8B6D-4D4ED486130A}" type="datetimeFigureOut">
               <a:rPr lang="en-BE" smtClean="0"/>
-              <a:t>06/04/2026</a:t>
+              <a:t>06/05/2026</a:t>
             </a:fld>
             <a:endParaRPr lang="en-BE"/>
           </a:p>
@@ -3663,6 +3663,36 @@
           </a:p>
         </p:txBody>
       </p:sp>
+      <p:pic>
+        <p:nvPicPr>
+          <p:cNvPr id="27" name="Afbeelding 26">
+            <a:extLst>
+              <a:ext uri="{FF2B5EF4-FFF2-40B4-BE49-F238E27FC236}">
+                <a16:creationId xmlns:a16="http://schemas.microsoft.com/office/drawing/2014/main" id="{71F8C478-7A59-01A7-2ED5-00B1431F8EA7}"/>
+              </a:ext>
+            </a:extLst>
+          </p:cNvPr>
+          <p:cNvPicPr>
+            <a:picLocks noChangeAspect="1"/>
+          </p:cNvPicPr>
+          <p:nvPr/>
+        </p:nvPicPr>
+        <p:blipFill>
+          <a:blip r:embed="rId2"/>
+          <a:stretch>
+            <a:fillRect/>
+          </a:stretch>
+        </p:blipFill>
+        <p:spPr>
+          <a:xfrm>
+            <a:off x="0" y="1690688"/>
+            <a:ext cx="12192000" cy="3994172"/>
+          </a:xfrm>
+          <a:prstGeom prst="rect">
+            <a:avLst/>
+          </a:prstGeom>
+        </p:spPr>
+      </p:pic>
     </p:spTree>
     <p:extLst>
       <p:ext uri="{BB962C8B-B14F-4D97-AF65-F5344CB8AC3E}">
@@ -3693,6 +3723,36 @@
           <a:chExt cx="0" cy="0"/>
         </a:xfrm>
       </p:grpSpPr>
+      <p:pic>
+        <p:nvPicPr>
+          <p:cNvPr id="5" name="Afbeelding 4">
+            <a:extLst>
+              <a:ext uri="{FF2B5EF4-FFF2-40B4-BE49-F238E27FC236}">
+                <a16:creationId xmlns:a16="http://schemas.microsoft.com/office/drawing/2014/main" id="{7C7A22F4-B8B4-F659-8B1F-2A4405FD1482}"/>
+              </a:ext>
+            </a:extLst>
+          </p:cNvPr>
+          <p:cNvPicPr>
+            <a:picLocks noChangeAspect="1"/>
+          </p:cNvPicPr>
+          <p:nvPr/>
+        </p:nvPicPr>
+        <p:blipFill>
+          <a:blip r:embed="rId2"/>
+          <a:stretch>
+            <a:fillRect/>
+          </a:stretch>
+        </p:blipFill>
+        <p:spPr>
+          <a:xfrm>
+            <a:off x="4251960" y="0"/>
+            <a:ext cx="7940040" cy="4145125"/>
+          </a:xfrm>
+          <a:prstGeom prst="rect">
+            <a:avLst/>
+          </a:prstGeom>
+        </p:spPr>
+      </p:pic>
       <p:sp>
         <p:nvSpPr>
           <p:cNvPr id="2" name="Title 1">
@@ -3715,64 +3775,10 @@
           <a:lstStyle/>
           <a:p>
             <a:r>
-              <a:rPr lang="en-US"/>
+              <a:rPr lang="en-US" dirty="0"/>
               <a:t>Enemy handling</a:t>
             </a:r>
-            <a:endParaRPr lang="en-BE"/>
-          </a:p>
-        </p:txBody>
-      </p:sp>
-      <p:sp>
-        <p:nvSpPr>
-          <p:cNvPr id="3" name="Content Placeholder 2">
-            <a:extLst>
-              <a:ext uri="{FF2B5EF4-FFF2-40B4-BE49-F238E27FC236}">
-                <a16:creationId xmlns:a16="http://schemas.microsoft.com/office/drawing/2014/main" id="{64915428-ACD8-4B22-96DC-2806680ED3AB}"/>
-              </a:ext>
-            </a:extLst>
-          </p:cNvPr>
-          <p:cNvSpPr>
-            <a:spLocks noGrp="1"/>
-          </p:cNvSpPr>
-          <p:nvPr>
-            <p:ph idx="1"/>
-          </p:nvPr>
-        </p:nvSpPr>
-        <p:spPr/>
-        <p:txBody>
-          <a:bodyPr/>
-          <a:lstStyle/>
-          <a:p>
-            <a:r>
-              <a:rPr lang="en-US" i="1">
-                <a:solidFill>
-                  <a:schemeClr val="bg1">
-                    <a:lumMod val="75000"/>
-                  </a:schemeClr>
-                </a:solidFill>
-              </a:rPr>
-              <a:t>How does your agent deal with enemies (aiming, shooting, item usage, avoidance, hiding, usage of sprint, …)?</a:t>
-            </a:r>
-            <a:endParaRPr lang="en-BE" i="1">
-              <a:solidFill>
-                <a:schemeClr val="bg1">
-                  <a:lumMod val="75000"/>
-                </a:schemeClr>
-              </a:solidFill>
-            </a:endParaRPr>
-          </a:p>
-          <a:p>
-            <a:r>
-              <a:rPr lang="en-US" i="1">
-                <a:solidFill>
-                  <a:schemeClr val="bg1">
-                    <a:lumMod val="75000"/>
-                  </a:schemeClr>
-                </a:solidFill>
-              </a:rPr>
-              <a:t>USE IMAGES/GIFS</a:t>
-            </a:r>
-            <a:endParaRPr lang="en-BE"/>
+            <a:endParaRPr lang="en-BE" dirty="0"/>
           </a:p>
         </p:txBody>
       </p:sp>
@@ -3806,6 +3812,36 @@
           <a:chExt cx="0" cy="0"/>
         </a:xfrm>
       </p:grpSpPr>
+      <p:pic>
+        <p:nvPicPr>
+          <p:cNvPr id="5" name="Afbeelding 4">
+            <a:extLst>
+              <a:ext uri="{FF2B5EF4-FFF2-40B4-BE49-F238E27FC236}">
+                <a16:creationId xmlns:a16="http://schemas.microsoft.com/office/drawing/2014/main" id="{C5E949E5-2AF9-52B1-19B9-A39DA88EE64B}"/>
+              </a:ext>
+            </a:extLst>
+          </p:cNvPr>
+          <p:cNvPicPr>
+            <a:picLocks noChangeAspect="1"/>
+          </p:cNvPicPr>
+          <p:nvPr/>
+        </p:nvPicPr>
+        <p:blipFill>
+          <a:blip r:embed="rId2"/>
+          <a:stretch>
+            <a:fillRect/>
+          </a:stretch>
+        </p:blipFill>
+        <p:spPr>
+          <a:xfrm>
+            <a:off x="0" y="768090"/>
+            <a:ext cx="12192000" cy="3054108"/>
+          </a:xfrm>
+          <a:prstGeom prst="rect">
+            <a:avLst/>
+          </a:prstGeom>
+        </p:spPr>
+      </p:pic>
       <p:sp>
         <p:nvSpPr>
           <p:cNvPr id="2" name="Title 1">
@@ -3835,47 +3871,96 @@
           </a:p>
         </p:txBody>
       </p:sp>
-      <p:sp>
-        <p:nvSpPr>
-          <p:cNvPr id="3" name="Content Placeholder 2">
-            <a:extLst>
-              <a:ext uri="{FF2B5EF4-FFF2-40B4-BE49-F238E27FC236}">
-                <a16:creationId xmlns:a16="http://schemas.microsoft.com/office/drawing/2014/main" id="{64915428-ACD8-4B22-96DC-2806680ED3AB}"/>
-              </a:ext>
-            </a:extLst>
-          </p:cNvPr>
-          <p:cNvSpPr>
-            <a:spLocks noGrp="1"/>
-          </p:cNvSpPr>
-          <p:nvPr>
-            <p:ph idx="1"/>
-          </p:nvPr>
-        </p:nvSpPr>
-        <p:spPr/>
-        <p:txBody>
-          <a:bodyPr/>
-          <a:lstStyle/>
-          <a:p>
-            <a:r>
-              <a:rPr lang="en-US" i="1" dirty="0">
-                <a:solidFill>
-                  <a:schemeClr val="bg1">
-                    <a:lumMod val="75000"/>
-                  </a:schemeClr>
-                </a:solidFill>
-              </a:rPr>
-              <a:t>How does your agent manage the inventory (inventory organization, item usage, picking up and remembering items,…)? </a:t>
-            </a:r>
-            <a:endParaRPr lang="en-BE" i="1" dirty="0">
-              <a:solidFill>
-                <a:schemeClr val="bg1">
-                  <a:lumMod val="75000"/>
-                </a:schemeClr>
-              </a:solidFill>
-            </a:endParaRPr>
-          </a:p>
-          <a:p>
-            <a:endParaRPr lang="en-BE" dirty="0"/>
+      <p:pic>
+        <p:nvPicPr>
+          <p:cNvPr id="9" name="Afbeelding 8">
+            <a:extLst>
+              <a:ext uri="{FF2B5EF4-FFF2-40B4-BE49-F238E27FC236}">
+                <a16:creationId xmlns:a16="http://schemas.microsoft.com/office/drawing/2014/main" id="{134E5546-FD55-DFE2-953C-C3B6401DE9B6}"/>
+              </a:ext>
+            </a:extLst>
+          </p:cNvPr>
+          <p:cNvPicPr>
+            <a:picLocks noChangeAspect="1"/>
+          </p:cNvPicPr>
+          <p:nvPr/>
+        </p:nvPicPr>
+        <p:blipFill>
+          <a:blip r:embed="rId3"/>
+          <a:srcRect l="5476" t="23732" r="7737" b="16001"/>
+          <a:stretch>
+            <a:fillRect/>
+          </a:stretch>
+        </p:blipFill>
+        <p:spPr>
+          <a:xfrm>
+            <a:off x="5318571" y="3429000"/>
+            <a:ext cx="5418872" cy="3300984"/>
+          </a:xfrm>
+          <a:prstGeom prst="rect">
+            <a:avLst/>
+          </a:prstGeom>
+        </p:spPr>
+      </p:pic>
+      <p:sp>
+        <p:nvSpPr>
+          <p:cNvPr id="10" name="Tekstvak 9">
+            <a:extLst>
+              <a:ext uri="{FF2B5EF4-FFF2-40B4-BE49-F238E27FC236}">
+                <a16:creationId xmlns:a16="http://schemas.microsoft.com/office/drawing/2014/main" id="{F03EF32A-B8F4-A3DB-4DAC-2CEDB106BB9F}"/>
+              </a:ext>
+            </a:extLst>
+          </p:cNvPr>
+          <p:cNvSpPr txBox="1"/>
+          <p:nvPr/>
+        </p:nvSpPr>
+        <p:spPr>
+          <a:xfrm>
+            <a:off x="0" y="3521765"/>
+            <a:ext cx="5418872" cy="1477328"/>
+          </a:xfrm>
+          <a:prstGeom prst="rect">
+            <a:avLst/>
+          </a:prstGeom>
+          <a:noFill/>
+        </p:spPr>
+        <p:txBody>
+          <a:bodyPr wrap="square" rtlCol="0">
+            <a:spAutoFit/>
+          </a:bodyPr>
+          <a:lstStyle/>
+          <a:p>
+            <a:r>
+              <a:rPr lang="en-US" dirty="0"/>
+              <a:t>• Inventory is checked before choosing a target item</a:t>
+            </a:r>
+          </a:p>
+          <a:p>
+            <a:r>
+              <a:rPr lang="en-US" dirty="0"/>
+              <a:t>• Items are scored using usefulness and distance</a:t>
+            </a:r>
+          </a:p>
+          <a:p>
+            <a:r>
+              <a:rPr lang="en-US" dirty="0"/>
+              <a:t>• Duplicates are ignored until the basic kit is complete</a:t>
+            </a:r>
+          </a:p>
+          <a:p>
+            <a:r>
+              <a:rPr lang="en-US" dirty="0"/>
+              <a:t>• </a:t>
+            </a:r>
+            <a:r>
+              <a:rPr lang="en-US" dirty="0" err="1"/>
+              <a:t>Medkits</a:t>
+            </a:r>
+            <a:r>
+              <a:rPr lang="en-US" dirty="0"/>
+              <a:t> and food become more important when health or stamina is low</a:t>
+            </a:r>
+            <a:endParaRPr lang="nl-BE" dirty="0"/>
           </a:p>
         </p:txBody>
       </p:sp>
@@ -3959,28 +4044,319 @@
           <a:bodyPr/>
           <a:lstStyle/>
           <a:p>
-            <a:r>
-              <a:rPr lang="en-US" i="1" dirty="0">
-                <a:solidFill>
-                  <a:schemeClr val="bg1">
-                    <a:lumMod val="75000"/>
-                  </a:schemeClr>
-                </a:solidFill>
-              </a:rPr>
-              <a:t>How many steering behaviors does it use? Does it use blended steering?</a:t>
-            </a:r>
-            <a:endParaRPr lang="en-BE" i="1" dirty="0">
-              <a:solidFill>
-                <a:schemeClr val="bg1">
-                  <a:lumMod val="75000"/>
-                </a:schemeClr>
-              </a:solidFill>
-            </a:endParaRPr>
-          </a:p>
-          <a:p>
             <a:pPr marL="0" indent="0">
               <a:buNone/>
             </a:pPr>
+            <a:r>
+              <a:rPr lang="nl-BE" dirty="0"/>
+              <a:t>• No full </a:t>
+            </a:r>
+            <a:r>
+              <a:rPr lang="nl-BE" dirty="0" err="1"/>
+              <a:t>SteeringBehavior</a:t>
+            </a:r>
+            <a:r>
+              <a:rPr lang="nl-BE" dirty="0"/>
+              <a:t> system was </a:t>
+            </a:r>
+            <a:r>
+              <a:rPr lang="nl-BE" dirty="0" err="1"/>
+              <a:t>implemented</a:t>
+            </a:r>
+            <a:endParaRPr lang="nl-BE" dirty="0"/>
+          </a:p>
+          <a:p>
+            <a:pPr marL="0" indent="0">
+              <a:buNone/>
+            </a:pPr>
+            <a:r>
+              <a:rPr lang="nl-BE" dirty="0"/>
+              <a:t>• </a:t>
+            </a:r>
+            <a:r>
+              <a:rPr lang="nl-BE" dirty="0" err="1"/>
+              <a:t>Movement</a:t>
+            </a:r>
+            <a:r>
+              <a:rPr lang="nl-BE" dirty="0"/>
+              <a:t> is </a:t>
+            </a:r>
+            <a:r>
+              <a:rPr lang="nl-BE" dirty="0" err="1"/>
+              <a:t>handled</a:t>
+            </a:r>
+            <a:r>
+              <a:rPr lang="nl-BE" dirty="0"/>
+              <a:t> </a:t>
+            </a:r>
+            <a:r>
+              <a:rPr lang="nl-BE" dirty="0" err="1"/>
+              <a:t>using</a:t>
+            </a:r>
+            <a:r>
+              <a:rPr lang="nl-BE" dirty="0"/>
+              <a:t> </a:t>
+            </a:r>
+            <a:r>
+              <a:rPr lang="nl-BE" dirty="0" err="1"/>
+              <a:t>Behavior</a:t>
+            </a:r>
+            <a:r>
+              <a:rPr lang="nl-BE" dirty="0"/>
+              <a:t> Tree </a:t>
+            </a:r>
+            <a:r>
+              <a:rPr lang="nl-BE" dirty="0" err="1"/>
+              <a:t>tasks</a:t>
+            </a:r>
+            <a:r>
+              <a:rPr lang="nl-BE" dirty="0"/>
+              <a:t> + </a:t>
+            </a:r>
+            <a:r>
+              <a:rPr lang="nl-BE" dirty="0" err="1"/>
+              <a:t>NavMesh</a:t>
+            </a:r>
+            <a:r>
+              <a:rPr lang="nl-BE" dirty="0"/>
+              <a:t> </a:t>
+            </a:r>
+            <a:r>
+              <a:rPr lang="nl-BE" dirty="0" err="1"/>
+              <a:t>MoveTo</a:t>
+            </a:r>
+            <a:endParaRPr lang="nl-BE" dirty="0"/>
+          </a:p>
+          <a:p>
+            <a:pPr marL="0" indent="0">
+              <a:buNone/>
+            </a:pPr>
+            <a:r>
+              <a:rPr lang="nl-BE" dirty="0"/>
+              <a:t>• </a:t>
+            </a:r>
+            <a:r>
+              <a:rPr lang="nl-BE" dirty="0" err="1"/>
+              <a:t>Flee</a:t>
+            </a:r>
+            <a:r>
+              <a:rPr lang="nl-BE" dirty="0"/>
+              <a:t>-style logic is </a:t>
+            </a:r>
+            <a:r>
+              <a:rPr lang="nl-BE" dirty="0" err="1"/>
+              <a:t>used</a:t>
+            </a:r>
+            <a:r>
+              <a:rPr lang="nl-BE" dirty="0"/>
+              <a:t> </a:t>
+            </a:r>
+            <a:r>
+              <a:rPr lang="nl-BE" dirty="0" err="1"/>
+              <a:t>to</a:t>
+            </a:r>
+            <a:r>
+              <a:rPr lang="nl-BE" dirty="0"/>
+              <a:t> </a:t>
+            </a:r>
+            <a:r>
+              <a:rPr lang="nl-BE" dirty="0" err="1"/>
+              <a:t>calculate</a:t>
+            </a:r>
+            <a:r>
+              <a:rPr lang="nl-BE" dirty="0"/>
+              <a:t> escape targets:</a:t>
+            </a:r>
+          </a:p>
+          <a:p>
+            <a:pPr marL="0" indent="0">
+              <a:buNone/>
+            </a:pPr>
+            <a:r>
+              <a:rPr lang="nl-BE" dirty="0"/>
+              <a:t>  - </a:t>
+            </a:r>
+            <a:r>
+              <a:rPr lang="nl-BE" dirty="0" err="1"/>
+              <a:t>Enemy</a:t>
+            </a:r>
+            <a:r>
+              <a:rPr lang="nl-BE" dirty="0"/>
+              <a:t> </a:t>
+            </a:r>
+            <a:r>
+              <a:rPr lang="nl-BE" dirty="0" err="1"/>
+              <a:t>flee</a:t>
+            </a:r>
+            <a:r>
+              <a:rPr lang="nl-BE" dirty="0"/>
+              <a:t> = </a:t>
+            </a:r>
+            <a:r>
+              <a:rPr lang="nl-BE" dirty="0" err="1"/>
+              <a:t>location</a:t>
+            </a:r>
+            <a:r>
+              <a:rPr lang="nl-BE" dirty="0"/>
+              <a:t> </a:t>
+            </a:r>
+            <a:r>
+              <a:rPr lang="nl-BE" dirty="0" err="1"/>
+              <a:t>away</a:t>
+            </a:r>
+            <a:r>
+              <a:rPr lang="nl-BE" dirty="0"/>
+              <a:t> </a:t>
+            </a:r>
+            <a:r>
+              <a:rPr lang="nl-BE" dirty="0" err="1"/>
+              <a:t>from</a:t>
+            </a:r>
+            <a:r>
+              <a:rPr lang="nl-BE" dirty="0"/>
+              <a:t> </a:t>
+            </a:r>
+            <a:r>
+              <a:rPr lang="nl-BE" dirty="0" err="1"/>
+              <a:t>TargetEnemy</a:t>
+            </a:r>
+            <a:endParaRPr lang="nl-BE" dirty="0"/>
+          </a:p>
+          <a:p>
+            <a:pPr marL="0" indent="0">
+              <a:buNone/>
+            </a:pPr>
+            <a:r>
+              <a:rPr lang="nl-BE" dirty="0"/>
+              <a:t>  - Purge escape = </a:t>
+            </a:r>
+            <a:r>
+              <a:rPr lang="nl-BE" dirty="0" err="1"/>
+              <a:t>location</a:t>
+            </a:r>
+            <a:r>
+              <a:rPr lang="nl-BE" dirty="0"/>
+              <a:t> </a:t>
+            </a:r>
+            <a:r>
+              <a:rPr lang="nl-BE" dirty="0" err="1"/>
+              <a:t>away</a:t>
+            </a:r>
+            <a:r>
+              <a:rPr lang="nl-BE" dirty="0"/>
+              <a:t> </a:t>
+            </a:r>
+            <a:r>
+              <a:rPr lang="nl-BE" dirty="0" err="1"/>
+              <a:t>from</a:t>
+            </a:r>
+            <a:r>
+              <a:rPr lang="nl-BE" dirty="0"/>
+              <a:t> </a:t>
+            </a:r>
+            <a:r>
+              <a:rPr lang="nl-BE" dirty="0" err="1"/>
+              <a:t>TargetPurgeZone</a:t>
+            </a:r>
+            <a:endParaRPr lang="nl-BE" dirty="0"/>
+          </a:p>
+          <a:p>
+            <a:pPr marL="0" indent="0">
+              <a:buNone/>
+            </a:pPr>
+            <a:r>
+              <a:rPr lang="nl-BE" dirty="0"/>
+              <a:t>• Exploration </a:t>
+            </a:r>
+            <a:r>
+              <a:rPr lang="nl-BE" dirty="0" err="1"/>
+              <a:t>uses</a:t>
+            </a:r>
+            <a:r>
+              <a:rPr lang="nl-BE" dirty="0"/>
+              <a:t> </a:t>
+            </a:r>
+            <a:r>
+              <a:rPr lang="nl-BE" dirty="0" err="1"/>
+              <a:t>randomized</a:t>
+            </a:r>
+            <a:r>
+              <a:rPr lang="nl-BE" dirty="0"/>
+              <a:t> </a:t>
+            </a:r>
+            <a:r>
+              <a:rPr lang="nl-BE" dirty="0" err="1"/>
+              <a:t>reachable</a:t>
+            </a:r>
+            <a:r>
+              <a:rPr lang="nl-BE" dirty="0"/>
+              <a:t> </a:t>
+            </a:r>
+            <a:r>
+              <a:rPr lang="nl-BE" dirty="0" err="1"/>
+              <a:t>NavMesh</a:t>
+            </a:r>
+            <a:r>
+              <a:rPr lang="nl-BE" dirty="0"/>
+              <a:t> targets</a:t>
+            </a:r>
+          </a:p>
+          <a:p>
+            <a:pPr marL="0" indent="0">
+              <a:buNone/>
+            </a:pPr>
+            <a:r>
+              <a:rPr lang="nl-BE" dirty="0"/>
+              <a:t>• </a:t>
+            </a:r>
+            <a:r>
+              <a:rPr lang="nl-BE" dirty="0" err="1"/>
+              <a:t>Final</a:t>
+            </a:r>
+            <a:r>
+              <a:rPr lang="nl-BE" dirty="0"/>
+              <a:t> </a:t>
+            </a:r>
+            <a:r>
+              <a:rPr lang="nl-BE" dirty="0" err="1"/>
+              <a:t>movement</a:t>
+            </a:r>
+            <a:r>
+              <a:rPr lang="nl-BE" dirty="0"/>
+              <a:t> is </a:t>
+            </a:r>
+            <a:r>
+              <a:rPr lang="nl-BE" dirty="0" err="1"/>
+              <a:t>executed</a:t>
+            </a:r>
+            <a:r>
+              <a:rPr lang="nl-BE" dirty="0"/>
+              <a:t> </a:t>
+            </a:r>
+            <a:r>
+              <a:rPr lang="nl-BE" dirty="0" err="1"/>
+              <a:t>by</a:t>
+            </a:r>
+            <a:r>
+              <a:rPr lang="nl-BE" dirty="0"/>
+              <a:t> </a:t>
+            </a:r>
+            <a:r>
+              <a:rPr lang="nl-BE" dirty="0" err="1"/>
+              <a:t>Unreal’s</a:t>
+            </a:r>
+            <a:r>
+              <a:rPr lang="nl-BE" dirty="0"/>
+              <a:t> </a:t>
+            </a:r>
+            <a:r>
+              <a:rPr lang="nl-BE" dirty="0" err="1"/>
+              <a:t>navigation</a:t>
+            </a:r>
+            <a:r>
+              <a:rPr lang="nl-BE" dirty="0"/>
+              <a:t> system</a:t>
+            </a:r>
             <a:endParaRPr lang="en-BE" dirty="0"/>
           </a:p>
         </p:txBody>
@@ -4050,10 +4426,10 @@
       </p:sp>
       <p:sp>
         <p:nvSpPr>
-          <p:cNvPr id="3" name="Content Placeholder 2">
-            <a:extLst>
-              <a:ext uri="{FF2B5EF4-FFF2-40B4-BE49-F238E27FC236}">
-                <a16:creationId xmlns:a16="http://schemas.microsoft.com/office/drawing/2014/main" id="{64915428-ACD8-4B22-96DC-2806680ED3AB}"/>
+          <p:cNvPr id="5" name="Tijdelijke aanduiding voor inhoud 4">
+            <a:extLst>
+              <a:ext uri="{FF2B5EF4-FFF2-40B4-BE49-F238E27FC236}">
+                <a16:creationId xmlns:a16="http://schemas.microsoft.com/office/drawing/2014/main" id="{4EBC7278-024E-926A-ACC6-BA6F3C423C37}"/>
               </a:ext>
             </a:extLst>
           </p:cNvPr>
@@ -4069,37 +4445,40 @@
           <a:bodyPr/>
           <a:lstStyle/>
           <a:p>
-            <a:r>
-              <a:rPr lang="en-US" i="1" dirty="0">
-                <a:solidFill>
-                  <a:schemeClr val="bg1">
-                    <a:lumMod val="75000"/>
-                  </a:schemeClr>
-                </a:solidFill>
-              </a:rPr>
-              <a:t>How does your agent explore the world ( how does it traverse the world, when and why does it visit houses, does it have a memory?)?</a:t>
-            </a:r>
-          </a:p>
-          <a:p>
-            <a:r>
-              <a:rPr lang="en-US" i="1" dirty="0">
-                <a:solidFill>
-                  <a:schemeClr val="bg1">
-                    <a:lumMod val="75000"/>
-                  </a:schemeClr>
-                </a:solidFill>
-              </a:rPr>
-              <a:t>USE IMAGES/GIFS</a:t>
-            </a:r>
-          </a:p>
-          <a:p>
-            <a:pPr marL="0" indent="0">
-              <a:buNone/>
-            </a:pPr>
-            <a:endParaRPr lang="en-BE" dirty="0"/>
-          </a:p>
-        </p:txBody>
-      </p:sp>
+            <a:endParaRPr lang="nl-BE" dirty="0"/>
+          </a:p>
+        </p:txBody>
+      </p:sp>
+      <p:pic>
+        <p:nvPicPr>
+          <p:cNvPr id="7" name="Afbeelding 6">
+            <a:extLst>
+              <a:ext uri="{FF2B5EF4-FFF2-40B4-BE49-F238E27FC236}">
+                <a16:creationId xmlns:a16="http://schemas.microsoft.com/office/drawing/2014/main" id="{304A9379-0708-916A-EA63-3D0284102CAA}"/>
+              </a:ext>
+            </a:extLst>
+          </p:cNvPr>
+          <p:cNvPicPr>
+            <a:picLocks noChangeAspect="1"/>
+          </p:cNvPicPr>
+          <p:nvPr/>
+        </p:nvPicPr>
+        <p:blipFill>
+          <a:blip r:embed="rId2"/>
+          <a:stretch>
+            <a:fillRect/>
+          </a:stretch>
+        </p:blipFill>
+        <p:spPr>
+          <a:xfrm>
+            <a:off x="6863052" y="0"/>
+            <a:ext cx="5328948" cy="5568696"/>
+          </a:xfrm>
+          <a:prstGeom prst="rect">
+            <a:avLst/>
+          </a:prstGeom>
+        </p:spPr>
+      </p:pic>
     </p:spTree>
     <p:extLst>
       <p:ext uri="{BB962C8B-B14F-4D97-AF65-F5344CB8AC3E}">
@@ -4418,21 +4797,6 @@
 </file>
 
 <file path=customXml/item2.xml><?xml version="1.0" encoding="utf-8"?>
-<p:properties xmlns:p="http://schemas.microsoft.com/office/2006/metadata/properties" xmlns:xsi="http://www.w3.org/2001/XMLSchema-instance" xmlns:pc="http://schemas.microsoft.com/office/infopath/2007/PartnerControls">
-  <documentManagement>
-    <IconOverlay xmlns="http://schemas.microsoft.com/sharepoint/v4" xsi:nil="true"/>
-    <TaxCatchAll xmlns="128482ec-0431-40d5-ab26-89ea2a4f3ccd" xsi:nil="true"/>
-    <m99485b88215436a82099f8287cba0b0 xmlns="128482ec-0431-40d5-ab26-89ea2a4f3ccd">
-      <Terms xmlns="http://schemas.microsoft.com/office/infopath/2007/PartnerControls"/>
-    </m99485b88215436a82099f8287cba0b0>
-    <lcf76f155ced4ddcb4097134ff3c332f xmlns="60eb0cf4-ae2a-4762-800a-cb593b869ecb">
-      <Terms xmlns="http://schemas.microsoft.com/office/infopath/2007/PartnerControls"/>
-    </lcf76f155ced4ddcb4097134ff3c332f>
-  </documentManagement>
-</p:properties>
-</file>
-
-<file path=customXml/item3.xml><?xml version="1.0" encoding="utf-8"?>
 <ct:contentTypeSchema xmlns:ct="http://schemas.microsoft.com/office/2006/metadata/contentType" xmlns:ma="http://schemas.microsoft.com/office/2006/metadata/properties/metaAttributes" ct:_="" ma:_="" ma:contentTypeName="Document" ma:contentTypeID="0x010100723942CCEB3A674D8F1F6472CCEFB38E" ma:contentTypeVersion="11" ma:contentTypeDescription="Create a new document." ma:contentTypeScope="" ma:versionID="e4de40d148e029d40e3aaddc8bf68a5e">
   <xsd:schema xmlns:xsd="http://www.w3.org/2001/XMLSchema" xmlns:xs="http://www.w3.org/2001/XMLSchema" xmlns:p="http://schemas.microsoft.com/office/2006/metadata/properties" xmlns:ns2="128482ec-0431-40d5-ab26-89ea2a4f3ccd" xmlns:ns3="60eb0cf4-ae2a-4762-800a-cb593b869ecb" xmlns:ns4="http://schemas.microsoft.com/sharepoint/v4" xmlns:ns5="a2e691a9-fcfc-4d85-a390-1894fe98bd9e" targetNamespace="http://schemas.microsoft.com/office/2006/metadata/properties" ma:root="true" ma:fieldsID="fce8e8bd091658f3fe51b22d57dec109" ns2:_="" ns3:_="" ns4:_="" ns5:_="">
     <xsd:import namespace="128482ec-0431-40d5-ab26-89ea2a4f3ccd"/>
@@ -4705,6 +5069,21 @@
 </ct:contentTypeSchema>
 </file>
 
+<file path=customXml/item3.xml><?xml version="1.0" encoding="utf-8"?>
+<p:properties xmlns:p="http://schemas.microsoft.com/office/2006/metadata/properties" xmlns:xsi="http://www.w3.org/2001/XMLSchema-instance" xmlns:pc="http://schemas.microsoft.com/office/infopath/2007/PartnerControls">
+  <documentManagement>
+    <IconOverlay xmlns="http://schemas.microsoft.com/sharepoint/v4" xsi:nil="true"/>
+    <TaxCatchAll xmlns="128482ec-0431-40d5-ab26-89ea2a4f3ccd" xsi:nil="true"/>
+    <m99485b88215436a82099f8287cba0b0 xmlns="128482ec-0431-40d5-ab26-89ea2a4f3ccd">
+      <Terms xmlns="http://schemas.microsoft.com/office/infopath/2007/PartnerControls"/>
+    </m99485b88215436a82099f8287cba0b0>
+    <lcf76f155ced4ddcb4097134ff3c332f xmlns="60eb0cf4-ae2a-4762-800a-cb593b869ecb">
+      <Terms xmlns="http://schemas.microsoft.com/office/infopath/2007/PartnerControls"/>
+    </lcf76f155ced4ddcb4097134ff3c332f>
+  </documentManagement>
+</p:properties>
+</file>
+
 <file path=customXml/itemProps1.xml><?xml version="1.0" encoding="utf-8"?>
 <ds:datastoreItem xmlns:ds="http://schemas.openxmlformats.org/officeDocument/2006/customXml" ds:itemID="{AF8EC6D1-CB19-4400-AD0A-0C75CD884AEA}">
   <ds:schemaRefs>
@@ -4714,18 +5093,6 @@
 </file>
 
 <file path=customXml/itemProps2.xml><?xml version="1.0" encoding="utf-8"?>
-<ds:datastoreItem xmlns:ds="http://schemas.openxmlformats.org/officeDocument/2006/customXml" ds:itemID="{B743389A-7EE0-4951-8919-E91DD69E3687}">
-  <ds:schemaRefs>
-    <ds:schemaRef ds:uri="128482ec-0431-40d5-ab26-89ea2a4f3ccd"/>
-    <ds:schemaRef ds:uri="http://schemas.microsoft.com/office/2006/metadata/properties"/>
-    <ds:schemaRef ds:uri="http://schemas.microsoft.com/office/infopath/2007/PartnerControls"/>
-    <ds:schemaRef ds:uri="http://schemas.microsoft.com/sharepoint/v4"/>
-    <ds:schemaRef ds:uri="60eb0cf4-ae2a-4762-800a-cb593b869ecb"/>
-  </ds:schemaRefs>
-</ds:datastoreItem>
-</file>
-
-<file path=customXml/itemProps3.xml><?xml version="1.0" encoding="utf-8"?>
 <ds:datastoreItem xmlns:ds="http://schemas.openxmlformats.org/officeDocument/2006/customXml" ds:itemID="{D7B8C5DE-3345-4025-A942-C5AA68E55545}">
   <ds:schemaRefs>
     <ds:schemaRef ds:uri="http://schemas.microsoft.com/office/2006/metadata/contentType"/>
@@ -4744,4 +5111,16 @@
     <ds:schemaRef ds:uri="http://schemas.microsoft.com/internal/obd"/>
   </ds:schemaRefs>
 </ds:datastoreItem>
+</file>
+
+<file path=customXml/itemProps3.xml><?xml version="1.0" encoding="utf-8"?>
+<ds:datastoreItem xmlns:ds="http://schemas.openxmlformats.org/officeDocument/2006/customXml" ds:itemID="{B743389A-7EE0-4951-8919-E91DD69E3687}">
+  <ds:schemaRefs>
+    <ds:schemaRef ds:uri="128482ec-0431-40d5-ab26-89ea2a4f3ccd"/>
+    <ds:schemaRef ds:uri="http://schemas.microsoft.com/office/2006/metadata/properties"/>
+    <ds:schemaRef ds:uri="http://schemas.microsoft.com/office/infopath/2007/PartnerControls"/>
+    <ds:schemaRef ds:uri="http://schemas.microsoft.com/sharepoint/v4"/>
+    <ds:schemaRef ds:uri="60eb0cf4-ae2a-4762-800a-cb593b869ecb"/>
+  </ds:schemaRefs>
+</ds:datastoreItem>
 </file>
</xml_diff>